<commit_message>
Epic 4E.4: Apply Aktiv Grotesk font to all PPTX and DOCX templates
Replaces Calibri, Calibri Light, Arial, Helvetica, Trebuchet MS, Segoe UI
with Aktiv Grotesk across 13 PPTX files and 5 DOCX files via ZIP-level XML
patching (theme, slide masters, layouts, individual slides, styles, body).

- 13 PPTX files: 21,773 font attribute replacements total
- 5 DOCX files: 318 font attribute replacements total
- New script: tools/apply_aktiv_grotesk_font.py (re-runnable, idempotent)

Co-Authored-By: Claude Sonnet 4.6 <noreply@anthropic.com>
</commit_message>
<xml_diff>
--- a/Templates/executive-reporting/cra-executive-summary-v3.pptx
+++ b/Templates/executive-reporting/cra-executive-summary-v3.pptx
@@ -4211,7 +4211,7 @@
         <a:spcBef>
           <a:spcPct val="20000"/>
         </a:spcBef>
-        <a:buFont typeface="Arial"/>
+        <a:buFont typeface="Aktiv Grotesk"/>
         <a:buChar char="•"/>
         <a:defRPr sz="3200" kern="1200">
           <a:solidFill>
@@ -4226,7 +4226,7 @@
         <a:spcBef>
           <a:spcPct val="20000"/>
         </a:spcBef>
-        <a:buFont typeface="Arial"/>
+        <a:buFont typeface="Aktiv Grotesk"/>
         <a:buChar char="–"/>
         <a:defRPr sz="2800" kern="1200">
           <a:solidFill>
@@ -4241,7 +4241,7 @@
         <a:spcBef>
           <a:spcPct val="20000"/>
         </a:spcBef>
-        <a:buFont typeface="Arial"/>
+        <a:buFont typeface="Aktiv Grotesk"/>
         <a:buChar char="•"/>
         <a:defRPr sz="2400" kern="1200">
           <a:solidFill>
@@ -4256,7 +4256,7 @@
         <a:spcBef>
           <a:spcPct val="20000"/>
         </a:spcBef>
-        <a:buFont typeface="Arial"/>
+        <a:buFont typeface="Aktiv Grotesk"/>
         <a:buChar char="–"/>
         <a:defRPr sz="2000" kern="1200">
           <a:solidFill>
@@ -4271,7 +4271,7 @@
         <a:spcBef>
           <a:spcPct val="20000"/>
         </a:spcBef>
-        <a:buFont typeface="Arial"/>
+        <a:buFont typeface="Aktiv Grotesk"/>
         <a:buChar char="»"/>
         <a:defRPr sz="2000" kern="1200">
           <a:solidFill>
@@ -4286,7 +4286,7 @@
         <a:spcBef>
           <a:spcPct val="20000"/>
         </a:spcBef>
-        <a:buFont typeface="Arial"/>
+        <a:buFont typeface="Aktiv Grotesk"/>
         <a:buChar char="•"/>
         <a:defRPr sz="2000" kern="1200">
           <a:solidFill>
@@ -4301,7 +4301,7 @@
         <a:spcBef>
           <a:spcPct val="20000"/>
         </a:spcBef>
-        <a:buFont typeface="Arial"/>
+        <a:buFont typeface="Aktiv Grotesk"/>
         <a:buChar char="•"/>
         <a:defRPr sz="2000" kern="1200">
           <a:solidFill>
@@ -4316,7 +4316,7 @@
         <a:spcBef>
           <a:spcPct val="20000"/>
         </a:spcBef>
-        <a:buFont typeface="Arial"/>
+        <a:buFont typeface="Aktiv Grotesk"/>
         <a:buChar char="•"/>
         <a:defRPr sz="2000" kern="1200">
           <a:solidFill>
@@ -4331,7 +4331,7 @@
         <a:spcBef>
           <a:spcPct val="20000"/>
         </a:spcBef>
-        <a:buFont typeface="Arial"/>
+        <a:buFont typeface="Aktiv Grotesk"/>
         <a:buChar char="•"/>
         <a:defRPr sz="2000" kern="1200">
           <a:solidFill>
@@ -35255,7 +35255,7 @@
     </a:clrScheme>
     <a:fontScheme name="Office">
       <a:majorFont>
-        <a:latin typeface="Calibri"/>
+        <a:latin typeface="Aktiv Grotesk"/>
         <a:ea typeface=""/>
         <a:cs typeface=""/>
         <a:font script="Jpan" typeface="ＭＳ Ｐゴシック"/>
@@ -35290,15 +35290,15 @@
         <a:font script="Geor" typeface="Sylfaen"/>
       </a:majorFont>
       <a:minorFont>
-        <a:latin typeface="Calibri"/>
+        <a:latin typeface="Aktiv Grotesk"/>
         <a:ea typeface=""/>
         <a:cs typeface=""/>
         <a:font script="Jpan" typeface="ＭＳ Ｐゴシック"/>
         <a:font script="Hang" typeface="맑은 고딕"/>
         <a:font script="Hans" typeface="宋体"/>
         <a:font script="Hant" typeface="新細明體"/>
-        <a:font script="Arab" typeface="Arial"/>
-        <a:font script="Hebr" typeface="Arial"/>
+        <a:font script="Arab" typeface="Aktiv Grotesk"/>
+        <a:font script="Hebr" typeface="Aktiv Grotesk"/>
         <a:font script="Thai" typeface="Cordia New"/>
         <a:font script="Ethi" typeface="Nyala"/>
         <a:font script="Beng" typeface="Vrinda"/>
@@ -35320,7 +35320,7 @@
         <a:font script="Laoo" typeface="DokChampa"/>
         <a:font script="Sinh" typeface="Iskoola Pota"/>
         <a:font script="Mong" typeface="Mongolian Baiti"/>
-        <a:font script="Viet" typeface="Arial"/>
+        <a:font script="Viet" typeface="Aktiv Grotesk"/>
         <a:font script="Uigh" typeface="Microsoft Uighur"/>
         <a:font script="Geor" typeface="Sylfaen"/>
       </a:minorFont>
@@ -35575,7 +35575,7 @@
     </a:clrScheme>
     <a:fontScheme name="Office">
       <a:majorFont>
-        <a:latin typeface="Calibri"/>
+        <a:latin typeface="Aktiv Grotesk"/>
         <a:ea typeface=""/>
         <a:cs typeface=""/>
         <a:font script="Jpan" typeface="ＭＳ Ｐゴシック"/>
@@ -35610,15 +35610,15 @@
         <a:font script="Geor" typeface="Sylfaen"/>
       </a:majorFont>
       <a:minorFont>
-        <a:latin typeface="Calibri"/>
+        <a:latin typeface="Aktiv Grotesk"/>
         <a:ea typeface=""/>
         <a:cs typeface=""/>
         <a:font script="Jpan" typeface="ＭＳ Ｐゴシック"/>
         <a:font script="Hang" typeface="맑은 고딕"/>
         <a:font script="Hans" typeface="宋体"/>
         <a:font script="Hant" typeface="新細明體"/>
-        <a:font script="Arab" typeface="Arial"/>
-        <a:font script="Hebr" typeface="Arial"/>
+        <a:font script="Arab" typeface="Aktiv Grotesk"/>
+        <a:font script="Hebr" typeface="Aktiv Grotesk"/>
         <a:font script="Thai" typeface="Cordia New"/>
         <a:font script="Ethi" typeface="Nyala"/>
         <a:font script="Beng" typeface="Vrinda"/>
@@ -35640,7 +35640,7 @@
         <a:font script="Laoo" typeface="DokChampa"/>
         <a:font script="Sinh" typeface="Iskoola Pota"/>
         <a:font script="Mong" typeface="Mongolian Baiti"/>
-        <a:font script="Viet" typeface="Arial"/>
+        <a:font script="Viet" typeface="Aktiv Grotesk"/>
         <a:font script="Uigh" typeface="Microsoft Uighur"/>
         <a:font script="Geor" typeface="Sylfaen"/>
       </a:minorFont>

</xml_diff>